<commit_message>
feat: enhance technical objectives aligned with CSE494 syllabus, redesign human-centric UI, and update presentation deck
</commit_message>
<xml_diff>
--- a/GeoPulse_Presentation_Fixed.pptx
+++ b/GeoPulse_Presentation_Fixed.pptx
@@ -4331,7 +4331,7 @@
               </a:defRPr>
             </a:pPr>
             <a:r>
-              <a:t>02 / SOLUTION &amp; FEATURES</a:t>
+              <a:t>02 / ACADEMIC &amp; TECHNICAL SCOPE</a:t>
             </a:r>
           </a:p>
           <a:p>
@@ -4347,7 +4347,7 @@
               </a:defRPr>
             </a:pPr>
             <a:r>
-              <a:t>Project Objective &amp; Solution Overview</a:t>
+              <a:t>Project Objectives &amp; Architectural Goals</a:t>
             </a:r>
           </a:p>
           <a:p>
@@ -4363,7 +4363,7 @@
               </a:defRPr>
             </a:pPr>
             <a:r>
-              <a:t>GeoPulse bridges the gap between stranded victims, field rescue squads, and relief hubs.</a:t>
+              <a:t>Engineered specifically to fulfill CSE494 Course Outcomes (CO1-CO6) using pure MongoDB capabilities.</a:t>
             </a:r>
           </a:p>
         </p:txBody>
@@ -4377,7 +4377,7 @@
         <p:spPr>
           <a:xfrm>
             <a:off x="731520" y="1874519"/>
-            <a:ext cx="4389120" cy="4480560"/>
+            <a:ext cx="4663440" cy="4480560"/>
           </a:xfrm>
           <a:prstGeom prst="roundRect">
             <a:avLst/>
@@ -4421,8 +4421,8 @@
         </p:nvSpPr>
         <p:spPr>
           <a:xfrm>
-            <a:off x="1005840" y="2103120"/>
-            <a:ext cx="3840480" cy="4023360"/>
+            <a:off x="960120" y="2057400"/>
+            <a:ext cx="4206240" cy="4114800"/>
           </a:xfrm>
           <a:prstGeom prst="rect">
             <a:avLst/>
@@ -4444,7 +4444,23 @@
               </a:defRPr>
             </a:pPr>
             <a:r>
-              <a:t>PRIMARY PROJECT OBJECTIVE</a:t>
+              <a:t>CORE PROJECT OBJECTIVES</a:t>
+            </a:r>
+          </a:p>
+          <a:p>
+            <a:pPr>
+              <a:spcBef>
+                <a:spcPts val="600"/>
+              </a:spcBef>
+              <a:defRPr sz="1200" b="1">
+                <a:solidFill>
+                  <a:srgbClr val="FFFFFF"/>
+                </a:solidFill>
+                <a:latin typeface="Segoe UI"/>
+              </a:defRPr>
+            </a:pPr>
+            <a:r>
+              <a:t>To engineer an intelligent, event-driven disaster response system that uses MongoDB's native 2dsphere indexing and aggregation pipelines to eliminate dispatch latency during critical first-hour calamity rescue operations.</a:t>
             </a:r>
           </a:p>
           <a:p>
@@ -4452,23 +4468,7 @@
               <a:spcBef>
                 <a:spcPts val="800"/>
               </a:spcBef>
-              <a:defRPr sz="1350" b="1">
-                <a:solidFill>
-                  <a:srgbClr val="FFFFFF"/>
-                </a:solidFill>
-                <a:latin typeface="Segoe UI"/>
-              </a:defRPr>
-            </a:pPr>
-            <a:r>
-              <a:t>To engineer an intelligent, event-driven disaster response system that uses MongoDB's native geospatial indexing and change streams to dynamically pair emergency SOS requests with nearest shelters and volunteers in milliseconds.</a:t>
-            </a:r>
-          </a:p>
-          <a:p>
-            <a:pPr>
-              <a:spcBef>
-                <a:spcPts val="1200"/>
-              </a:spcBef>
-              <a:defRPr sz="1150" b="1">
+              <a:defRPr sz="1050" b="1">
                 <a:solidFill>
                   <a:srgbClr val="38BDF8"/>
                 </a:solidFill>
@@ -4476,7 +4476,7 @@
               </a:defRPr>
             </a:pPr>
             <a:r>
-              <a:t>Key Architectural Pillars:</a:t>
+              <a:t>Specific Technical Objectives (Syllabus Mapped):</a:t>
             </a:r>
           </a:p>
           <a:p>
@@ -4484,7 +4484,7 @@
               <a:spcBef>
                 <a:spcPts val="400"/>
               </a:spcBef>
-              <a:defRPr sz="1050">
+              <a:defRPr sz="950">
                 <a:solidFill>
                   <a:srgbClr val="CBD5E1"/>
                 </a:solidFill>
@@ -4492,7 +4492,7 @@
               </a:defRPr>
             </a:pPr>
             <a:r>
-              <a:t>• Eliminates external message brokers (No Redis or Kafka needed).</a:t>
+              <a:t>• 1. Sub-100ms $geoNear Matching: Native spherical distance computation over Earth's curvature (Unit IV).</a:t>
             </a:r>
           </a:p>
           <a:p>
@@ -4500,7 +4500,7 @@
               <a:spcBef>
                 <a:spcPts val="400"/>
               </a:spcBef>
-              <a:defRPr sz="1050">
+              <a:defRPr sz="950">
                 <a:solidFill>
                   <a:srgbClr val="CBD5E1"/>
                 </a:solidFill>
@@ -4508,7 +4508,7 @@
               </a:defRPr>
             </a:pPr>
             <a:r>
-              <a:t>• Executes spherical curvature distance queries directly inside MongoDB.</a:t>
+              <a:t>• 2. Multi-Stage Aggregation Triage: Dynamic scoring combining severity, casualty count, and proximity (Unit IV).</a:t>
             </a:r>
           </a:p>
           <a:p>
@@ -4516,7 +4516,7 @@
               <a:spcBef>
                 <a:spcPts val="400"/>
               </a:spcBef>
-              <a:defRPr sz="1050">
+              <a:defRPr sz="950">
                 <a:solidFill>
                   <a:srgbClr val="CBD5E1"/>
                 </a:solidFill>
@@ -4524,7 +4524,39 @@
               </a:defRPr>
             </a:pPr>
             <a:r>
-              <a:t>• Pushes real-time dashboard updates in &lt;80ms via native Change Streams.</a:t>
+              <a:t>• 3. Autonomous TTL Lifecycle: Native self-cleaning of resolved alerts after 48h without background cron jobs (Unit II).</a:t>
+            </a:r>
+          </a:p>
+          <a:p>
+            <a:pPr>
+              <a:spcBef>
+                <a:spcPts val="400"/>
+              </a:spcBef>
+              <a:defRPr sz="950">
+                <a:solidFill>
+                  <a:srgbClr val="CBD5E1"/>
+                </a:solidFill>
+                <a:latin typeface="Segoe UI"/>
+              </a:defRPr>
+            </a:pPr>
+            <a:r>
+              <a:t>• 4. Zero-Broker Event Push: Streaming live database state via MongoDB Change Streams without Redis/Kafka (Unit V).</a:t>
+            </a:r>
+          </a:p>
+          <a:p>
+            <a:pPr>
+              <a:spcBef>
+                <a:spcPts val="400"/>
+              </a:spcBef>
+              <a:defRPr sz="950">
+                <a:solidFill>
+                  <a:srgbClr val="CBD5E1"/>
+                </a:solidFill>
+                <a:latin typeface="Segoe UI"/>
+              </a:defRPr>
+            </a:pPr>
+            <a:r>
+              <a:t>• 5. Polymorphic GeoJSON Modeling: Embedded BSON Point schemas supporting diverse calamity attributes (Unit III).</a:t>
             </a:r>
           </a:p>
         </p:txBody>
@@ -4537,8 +4569,8 @@
         </p:nvSpPr>
         <p:spPr>
           <a:xfrm>
-            <a:off x="5394960" y="1874519"/>
-            <a:ext cx="6035040" cy="987552"/>
+            <a:off x="5577840" y="1874519"/>
+            <a:ext cx="5852160" cy="987552"/>
           </a:xfrm>
           <a:prstGeom prst="roundRect">
             <a:avLst/>
@@ -4582,7 +4614,7 @@
         </p:nvSpPr>
         <p:spPr>
           <a:xfrm>
-            <a:off x="5532120" y="2057399"/>
+            <a:off x="5715000" y="2057399"/>
             <a:ext cx="54864" cy="621792"/>
           </a:xfrm>
           <a:prstGeom prst="rect">
@@ -4625,8 +4657,8 @@
         </p:nvSpPr>
         <p:spPr>
           <a:xfrm>
-            <a:off x="5715000" y="2011679"/>
-            <a:ext cx="5532120" cy="713232"/>
+            <a:off x="5897880" y="2011679"/>
+            <a:ext cx="5349240" cy="713232"/>
           </a:xfrm>
           <a:prstGeom prst="rect">
             <a:avLst/>
@@ -4640,7 +4672,7 @@
           <a:lstStyle/>
           <a:p>
             <a:pPr>
-              <a:defRPr sz="1200" b="1">
+              <a:defRPr sz="1150" b="1">
                 <a:solidFill>
                   <a:srgbClr val="FFFFFF"/>
                 </a:solidFill>
@@ -4648,13 +4680,13 @@
               </a:defRPr>
             </a:pPr>
             <a:r>
-              <a:t>One-Tap SOS Geolocation Beacon</a:t>
-            </a:r>
-          </a:p>
-          <a:p>
-            <a:pPr>
-              <a:spcBef>
-                <a:spcPts val="200"/>
+              <a:t>Obj 1: Hyperlocal Proximity Dispatch ($geoNear)</a:t>
+            </a:r>
+          </a:p>
+          <a:p>
+            <a:pPr>
+              <a:spcBef>
+                <a:spcPts val="300"/>
               </a:spcBef>
               <a:defRPr sz="1000">
                 <a:solidFill>
@@ -4664,7 +4696,7 @@
               </a:defRPr>
             </a:pPr>
             <a:r>
-              <a:t>Victims submit dynamic GPS coordinates, emergency category (Medical, Food, Evacuation), and casualty count.</a:t>
+              <a:t>Pair stranded victims with closest volunteers within a 15km radius in &lt;18ms using spherical indexing.</a:t>
             </a:r>
           </a:p>
         </p:txBody>
@@ -4677,8 +4709,8 @@
         </p:nvSpPr>
         <p:spPr>
           <a:xfrm>
-            <a:off x="5394960" y="3026663"/>
-            <a:ext cx="6035040" cy="987552"/>
+            <a:off x="5577840" y="3026663"/>
+            <a:ext cx="5852160" cy="987552"/>
           </a:xfrm>
           <a:prstGeom prst="roundRect">
             <a:avLst/>
@@ -4722,7 +4754,7 @@
         </p:nvSpPr>
         <p:spPr>
           <a:xfrm>
-            <a:off x="5532120" y="3209543"/>
+            <a:off x="5715000" y="3209543"/>
             <a:ext cx="54864" cy="621792"/>
           </a:xfrm>
           <a:prstGeom prst="rect">
@@ -4765,8 +4797,8 @@
         </p:nvSpPr>
         <p:spPr>
           <a:xfrm>
-            <a:off x="5715000" y="3163823"/>
-            <a:ext cx="5532120" cy="713232"/>
+            <a:off x="5897880" y="3163823"/>
+            <a:ext cx="5349240" cy="713232"/>
           </a:xfrm>
           <a:prstGeom prst="rect">
             <a:avLst/>
@@ -4780,7 +4812,7 @@
           <a:lstStyle/>
           <a:p>
             <a:pPr>
-              <a:defRPr sz="1200" b="1">
+              <a:defRPr sz="1150" b="1">
                 <a:solidFill>
                   <a:srgbClr val="FFFFFF"/>
                 </a:solidFill>
@@ -4788,13 +4820,13 @@
               </a:defRPr>
             </a:pPr>
             <a:r>
-              <a:t>Sub-100ms Spatial Matching ($geoNear)</a:t>
-            </a:r>
-          </a:p>
-          <a:p>
-            <a:pPr>
-              <a:spcBef>
-                <a:spcPts val="200"/>
+              <a:t>Obj 2: Multi-Stage Priority Aggregation Pipeline</a:t>
+            </a:r>
+          </a:p>
+          <a:p>
+            <a:pPr>
+              <a:spcBef>
+                <a:spcPts val="300"/>
               </a:spcBef>
               <a:defRPr sz="1000">
                 <a:solidFill>
@@ -4804,7 +4836,7 @@
               </a:defRPr>
             </a:pPr>
             <a:r>
-              <a:t>MongoDB evaluates earth curvature and immediately returns certified responders and shelters within a dynamic radius (e.g. 5km).</a:t>
+              <a:t>Execute server-side triage calculation in a single database roundtrip, eliminating application bottleneck.</a:t>
             </a:r>
           </a:p>
         </p:txBody>
@@ -4817,8 +4849,8 @@
         </p:nvSpPr>
         <p:spPr>
           <a:xfrm>
-            <a:off x="5394960" y="4178807"/>
-            <a:ext cx="6035040" cy="987552"/>
+            <a:off x="5577840" y="4178807"/>
+            <a:ext cx="5852160" cy="987552"/>
           </a:xfrm>
           <a:prstGeom prst="roundRect">
             <a:avLst/>
@@ -4862,7 +4894,7 @@
         </p:nvSpPr>
         <p:spPr>
           <a:xfrm>
-            <a:off x="5532120" y="4361687"/>
+            <a:off x="5715000" y="4361687"/>
             <a:ext cx="54864" cy="621792"/>
           </a:xfrm>
           <a:prstGeom prst="rect">
@@ -4905,8 +4937,8 @@
         </p:nvSpPr>
         <p:spPr>
           <a:xfrm>
-            <a:off x="5715000" y="4315967"/>
-            <a:ext cx="5532120" cy="713232"/>
+            <a:off x="5897880" y="4315967"/>
+            <a:ext cx="5349240" cy="713232"/>
           </a:xfrm>
           <a:prstGeom prst="rect">
             <a:avLst/>
@@ -4920,7 +4952,7 @@
           <a:lstStyle/>
           <a:p>
             <a:pPr>
-              <a:defRPr sz="1200" b="1">
+              <a:defRPr sz="1150" b="1">
                 <a:solidFill>
                   <a:srgbClr val="FFFFFF"/>
                 </a:solidFill>
@@ -4928,13 +4960,13 @@
               </a:defRPr>
             </a:pPr>
             <a:r>
-              <a:t>Zero-Broker Real-Time Streaming</a:t>
-            </a:r>
-          </a:p>
-          <a:p>
-            <a:pPr>
-              <a:spcBef>
-                <a:spcPts val="200"/>
+              <a:t>Obj 3: Autonomous TTL Data Purging (48h)</a:t>
+            </a:r>
+          </a:p>
+          <a:p>
+            <a:pPr>
+              <a:spcBef>
+                <a:spcPts val="300"/>
               </a:spcBef>
               <a:defRPr sz="1000">
                 <a:solidFill>
@@ -4944,7 +4976,7 @@
               </a:defRPr>
             </a:pPr>
             <a:r>
-              <a:t>MongoDB Change Streams watch the collections and push live mutation events to dispatchers via WebSockets.</a:t>
+              <a:t>Leverage MongoDB's background thread to expire closed incidents automatically on resolvedAt timestamp.</a:t>
             </a:r>
           </a:p>
         </p:txBody>
@@ -4957,8 +4989,8 @@
         </p:nvSpPr>
         <p:spPr>
           <a:xfrm>
-            <a:off x="5394960" y="5330951"/>
-            <a:ext cx="6035040" cy="987552"/>
+            <a:off x="5577840" y="5330951"/>
+            <a:ext cx="5852160" cy="987552"/>
           </a:xfrm>
           <a:prstGeom prst="roundRect">
             <a:avLst/>
@@ -5002,7 +5034,7 @@
         </p:nvSpPr>
         <p:spPr>
           <a:xfrm>
-            <a:off x="5532120" y="5513831"/>
+            <a:off x="5715000" y="5513831"/>
             <a:ext cx="54864" cy="621792"/>
           </a:xfrm>
           <a:prstGeom prst="rect">
@@ -5045,8 +5077,8 @@
         </p:nvSpPr>
         <p:spPr>
           <a:xfrm>
-            <a:off x="5715000" y="5468111"/>
-            <a:ext cx="5532120" cy="713232"/>
+            <a:off x="5897880" y="5468111"/>
+            <a:ext cx="5349240" cy="713232"/>
           </a:xfrm>
           <a:prstGeom prst="rect">
             <a:avLst/>
@@ -5060,7 +5092,7 @@
           <a:lstStyle/>
           <a:p>
             <a:pPr>
-              <a:defRPr sz="1200" b="1">
+              <a:defRPr sz="1150" b="1">
                 <a:solidFill>
                   <a:srgbClr val="FFFFFF"/>
                 </a:solidFill>
@@ -5068,13 +5100,13 @@
               </a:defRPr>
             </a:pPr>
             <a:r>
-              <a:t>Incident Lifecycle &amp; TTL Auto-Cleanup</a:t>
-            </a:r>
-          </a:p>
-          <a:p>
-            <a:pPr>
-              <a:spcBef>
-                <a:spcPts val="200"/>
+              <a:t>Obj 4: Hyperlocal Fleet Auto-Provisioning</a:t>
+            </a:r>
+          </a:p>
+          <a:p>
+            <a:pPr>
+              <a:spcBef>
+                <a:spcPts val="300"/>
               </a:spcBef>
               <a:defRPr sz="1000">
                 <a:solidFill>
@@ -5084,7 +5116,7 @@
               </a:defRPr>
             </a:pPr>
             <a:r>
-              <a:t>Built-in TTL (Time-To-Live) indexes automatically sunset resolved emergency alerts after 48h without cron tasks.</a:t>
+              <a:t>Dynamically commission local neighborhood rapid units when no pre-deployed crew is within range, leaving 0 victims unattended.</a:t>
             </a:r>
           </a:p>
         </p:txBody>

</xml_diff>

<commit_message>
refactor: replace course/syllabus references with professional systems engineering terminology
</commit_message>
<xml_diff>
--- a/GeoPulse_Presentation_Fixed.pptx
+++ b/GeoPulse_Presentation_Fixed.pptx
@@ -3175,7 +3175,7 @@
               </a:defRPr>
             </a:pPr>
             <a:r>
-              <a:t>ACADEMIC CAPSTONE PROJECT • COMPUTER SCIENCE &amp; ENGINEERING</a:t>
+              <a:t>SYSTEMS ENGINEERING • REAL-TIME DISASTER RELIEF PLATFORM</a:t>
             </a:r>
           </a:p>
           <a:p>
@@ -4331,7 +4331,7 @@
               </a:defRPr>
             </a:pPr>
             <a:r>
-              <a:t>02 / ACADEMIC &amp; TECHNICAL SCOPE</a:t>
+              <a:t>02 / ARCHITECTURAL SCOPE</a:t>
             </a:r>
           </a:p>
           <a:p>
@@ -4347,7 +4347,7 @@
               </a:defRPr>
             </a:pPr>
             <a:r>
-              <a:t>Project Objectives &amp; Architectural Goals</a:t>
+              <a:t>Project Objectives &amp; Engineering Goals</a:t>
             </a:r>
           </a:p>
           <a:p>
@@ -4363,7 +4363,7 @@
               </a:defRPr>
             </a:pPr>
             <a:r>
-              <a:t>Engineered specifically to fulfill CSE494 Course Outcomes (CO1-CO6) using pure MongoDB capabilities.</a:t>
+              <a:t>Engineered for low-latency disaster response using pure native MongoDB capabilities.</a:t>
             </a:r>
           </a:p>
         </p:txBody>
@@ -4476,7 +4476,7 @@
               </a:defRPr>
             </a:pPr>
             <a:r>
-              <a:t>Specific Technical Objectives (Syllabus Mapped):</a:t>
+              <a:t>Key Technical &amp; Engineering Objectives:</a:t>
             </a:r>
           </a:p>
           <a:p>
@@ -4492,7 +4492,7 @@
               </a:defRPr>
             </a:pPr>
             <a:r>
-              <a:t>• 1. Sub-100ms $geoNear Matching: Native spherical distance computation over Earth's curvature (Unit IV).</a:t>
+              <a:t>• 1. Sub-100ms $geoNear Matching: Native spherical distance computation over Earth's curvature.</a:t>
             </a:r>
           </a:p>
           <a:p>
@@ -4508,7 +4508,7 @@
               </a:defRPr>
             </a:pPr>
             <a:r>
-              <a:t>• 2. Multi-Stage Aggregation Triage: Dynamic scoring combining severity, casualty count, and proximity (Unit IV).</a:t>
+              <a:t>• 2. Multi-Stage Aggregation Triage: Dynamic scoring combining severity, casualty count, and proximity.</a:t>
             </a:r>
           </a:p>
           <a:p>
@@ -4524,7 +4524,7 @@
               </a:defRPr>
             </a:pPr>
             <a:r>
-              <a:t>• 3. Autonomous TTL Lifecycle: Native self-cleaning of resolved alerts after 48h without background cron jobs (Unit II).</a:t>
+              <a:t>• 3. Autonomous TTL Lifecycle: Native self-cleaning of resolved alerts after 48h without background cron jobs.</a:t>
             </a:r>
           </a:p>
           <a:p>
@@ -4540,7 +4540,7 @@
               </a:defRPr>
             </a:pPr>
             <a:r>
-              <a:t>• 4. Zero-Broker Event Push: Streaming live database state via MongoDB Change Streams without Redis/Kafka (Unit V).</a:t>
+              <a:t>• 4. Zero-Broker Event Push: Streaming live database state via MongoDB Change Streams without Redis/Kafka.</a:t>
             </a:r>
           </a:p>
           <a:p>
@@ -4556,7 +4556,7 @@
               </a:defRPr>
             </a:pPr>
             <a:r>
-              <a:t>• 5. Polymorphic GeoJSON Modeling: Embedded BSON Point schemas supporting diverse calamity attributes (Unit III).</a:t>
+              <a:t>• 5. Polymorphic GeoJSON Modeling: Embedded BSON Point schemas supporting diverse calamity attributes.</a:t>
             </a:r>
           </a:p>
         </p:txBody>

</xml_diff>